<commit_message>
Keep frame source attribution on final references slide
</commit_message>
<xml_diff>
--- a/presentation/GIG_Stage2_VK26-AU-HCI-0032_Repo_Linked.pptx
+++ b/presentation/GIG_Stage2_VK26-AU-HCI-0032_Repo_Linked.pptx
@@ -18505,7 +18505,7 @@
                 </a:solidFill>
                 <a:latin typeface="DM Sans"/>
               </a:rPr>
-              <a:t>Printable research gaze frames [S8]</a:t>
+              <a:t>Printable research gaze frames</a:t>
             </a:r>
           </a:p>
           <a:p>
@@ -19102,7 +19102,7 @@
                 </a:solidFill>
                 <a:latin typeface="DM Sans"/>
               </a:rPr>
-              <a:t> video debriefing is established (Laerdal SimCapture [S7]); GIG does not claim it as new. The open-source tools [S5, S8] do not make the GIG hardware open or compatible.</a:t>
+              <a:t> video debriefing is established (Laerdal SimCapture [S7]); GIG does not claim it as new. The open-source tools [S5] do not make the GIG hardware open or compatible.</a:t>
             </a:r>
           </a:p>
         </p:txBody>
@@ -21655,7 +21655,7 @@
                 </a:solidFill>
                 <a:latin typeface="DM Sans"/>
               </a:rPr>
-              <a:t>CAD files: original untested GIG temple .scad; third-party open-hardware frame .3mf/STLs and exploded reference drawing [S8].</a:t>
+              <a:t>CAD files: original untested GIG temple .scad; third-party open-hardware frame .3mf/STLs and exploded reference drawing.</a:t>
             </a:r>
           </a:p>
         </p:txBody>

</xml_diff>